<commit_message>
Fill supplier, substitute and complement boxes in six forces diagram
Co-Authored-By: Claude Opus 5.5 <noreply@anthropic.com>
Claude-Session: https://claude.ai/code/session_01TUy6cSUWqFzd9QVy2dyYha
</commit_message>
<xml_diff>
--- a/Appendix_A_six_forces.pptx
+++ b/Appendix_A_six_forces.pptx
@@ -3403,11 +3403,11 @@
             <a:r>
               <a:rPr sz="1300" b="1">
                 <a:solidFill>
-                  <a:srgbClr val="808080"/>
+                  <a:srgbClr val="C00000"/>
                 </a:solidFill>
                 <a:latin typeface="Times New Roman"/>
               </a:rPr>
-              <a:t>TBC</a:t>
+              <a:t>HIGH</a:t>
             </a:r>
           </a:p>
           <a:p>
@@ -3419,7 +3419,7 @@
                 </a:solidFill>
                 <a:latin typeface="Times New Roman"/>
               </a:rPr>
-              <a:t>Drivers to be added (B)</a:t>
+              <a:t>Concentrated battery makers; critical minerals</a:t>
             </a:r>
           </a:p>
         </p:txBody>
@@ -3663,11 +3663,11 @@
             <a:r>
               <a:rPr sz="1300" b="1">
                 <a:solidFill>
-                  <a:srgbClr val="808080"/>
+                  <a:srgbClr val="C55A11"/>
                 </a:solidFill>
                 <a:latin typeface="Times New Roman"/>
               </a:rPr>
-              <a:t>TBC</a:t>
+              <a:t>MEDIUM</a:t>
             </a:r>
           </a:p>
           <a:p>
@@ -3679,7 +3679,7 @@
                 </a:solidFill>
                 <a:latin typeface="Times New Roman"/>
               </a:rPr>
-              <a:t>Drivers to be added (C)</a:t>
+              <a:t>Hybrids &amp; ICE cars; transit; robotaxis</a:t>
             </a:r>
           </a:p>
         </p:txBody>
@@ -3793,11 +3793,11 @@
             <a:r>
               <a:rPr sz="1300" b="1">
                 <a:solidFill>
-                  <a:srgbClr val="808080"/>
+                  <a:srgbClr val="1F4E99"/>
                 </a:solidFill>
                 <a:latin typeface="Times New Roman"/>
               </a:rPr>
-              <a:t>TBC</a:t>
+              <a:t>KEY SWING FACTOR</a:t>
             </a:r>
           </a:p>
           <a:p>
@@ -3809,7 +3809,7 @@
                 </a:solidFill>
                 <a:latin typeface="Times New Roman"/>
               </a:rPr>
-              <a:t>Drivers to be added (C)</a:t>
+              <a:t>Charging network; software; power grid</a:t>
             </a:r>
           </a:p>
         </p:txBody>

</xml_diff>